<commit_message>
fix(decks): rebuild decks B and D without the Hermes content; fit the provenance labels
The tracked decks were last built on 2026-08-25 and still carried the
fabricated EN 1998-1 and DIN 4149 editions, the standard-pair sensitivity
labels, the US/European framing and the "Resolution rule" table. They are now
rebuilt from the corrected builders.

The full authored-calibration label overflowed its 3.2 in table cell, so:
- Deck B slide 10 and deck D slide 12: the cell reads "SB-001 authored
  calibration¹" and a footnote directly under the table carries
  "¹ BIMGUARD SB-001 screening calibration (authored thresholds, not code
  values)" verbatim.
- Deck B slide 17: the DIN EN 1998-1/NA:2018-10 row reads "German NA; DIN 4149
  withdrawn"; the note below keeps the full withdrawal wording.

Both builders import _text from build_fmp_decks for the footnote. No measured
number and no other layout changed.
</commit_message>
<xml_diff>
--- a/docs/Presentation-2026-May/BIMGUARD_FMP_B_Blue_Halo.pptx
+++ b/docs/Presentation-2026-May/BIMGUARD_FMP_B_Blue_Halo.pptx
@@ -996,7 +996,7 @@
                 </a:solidFill>
                 <a:latin typeface="Calibri"/>
               </a:rPr>
-              <a:t>EN 1998-1  ·  DIN 4149  ·  ASCE 7-22  ·  NFPA 13  ·  SMACNA  ·  MSS SP-58</a:t>
+              <a:t>FEMA E-74  ·  ASCE/SEI 7-10 §13.6  ·  EN 1998-1 + DIN EN 1998-1/NA  ·  NFPA 13  ·  SMACNA</a:t>
             </a:r>
           </a:p>
         </p:txBody>
@@ -2230,7 +2230,7 @@
                 </a:solidFill>
                 <a:latin typeface="Calibri"/>
               </a:rPr>
-              <a:t>EN 1998-1 + DIN 4149</a:t>
+              <a:t>SB-001 authored calibration¹</a:t>
             </a:r>
           </a:p>
         </p:txBody>
@@ -2471,7 +2471,7 @@
                 </a:solidFill>
                 <a:latin typeface="Calibri"/>
               </a:rPr>
-              <a:t>ASCE 7-22 + NFPA 13</a:t>
+              <a:t>—</a:t>
             </a:r>
           </a:p>
         </p:txBody>
@@ -2842,6 +2842,45 @@
         </p:nvSpPr>
         <p:spPr>
           <a:xfrm>
+            <a:off x="228600" y="2953512"/>
+            <a:ext cx="8686800" cy="182880"/>
+          </a:xfrm>
+          <a:prstGeom prst="rect">
+            <a:avLst/>
+          </a:prstGeom>
+          <a:noFill/>
+        </p:spPr>
+        <p:txBody>
+          <a:bodyPr wrap="square" anchor="t" lIns="0" rIns="0" tIns="0" bIns="0">
+            <a:spAutoFit/>
+          </a:bodyPr>
+          <a:lstStyle/>
+          <a:p>
+            <a:pPr algn="l">
+              <a:lnSpc>
+                <a:spcPct val="100000"/>
+              </a:lnSpc>
+            </a:pPr>
+            <a:r>
+              <a:rPr sz="900" b="0">
+                <a:solidFill>
+                  <a:srgbClr val="8896A6"/>
+                </a:solidFill>
+                <a:latin typeface="Calibri"/>
+              </a:rPr>
+              <a:t>¹ BIMGUARD SB-001 screening calibration (authored thresholds, not code values)</a:t>
+            </a:r>
+          </a:p>
+        </p:txBody>
+      </p:sp>
+      <p:sp>
+        <p:nvSpPr>
+          <p:cNvPr id="45" name="TextBox 44"/>
+          <p:cNvSpPr txBox="1"/>
+          <p:nvPr/>
+        </p:nvSpPr>
+        <p:spPr>
+          <a:xfrm>
             <a:off x="228600" y="3154680"/>
             <a:ext cx="8686800" cy="640080"/>
           </a:xfrm>
@@ -2868,14 +2907,14 @@
                 </a:solidFill>
                 <a:latin typeface="Calibri"/>
               </a:rPr>
-              <a:t>Adopting the US standard over the European yields 66% more clashes but 48% fewer Critical ones. Severity is an overlap ratio against halo volume, so a larger clearance inflates the denominator faster than the numerator.</a:t>
-            </a:r>
-          </a:p>
-        </p:txBody>
-      </p:sp>
-      <p:sp>
-        <p:nvSpPr>
-          <p:cNvPr id="45" name="TextBox 44"/>
+              <a:t>Raising the clearance from the 200 mm row to the 457.2 mm row yields 66% more clashes but 48% fewer Critical ones. Severity is an overlap ratio against halo volume, so a larger clearance inflates the denominator faster than the numerator.</a:t>
+            </a:r>
+          </a:p>
+        </p:txBody>
+      </p:sp>
+      <p:sp>
+        <p:nvSpPr>
+          <p:cNvPr id="46" name="TextBox 45"/>
           <p:cNvSpPr txBox="1"/>
           <p:nvPr/>
         </p:nvSpPr>
@@ -8725,7 +8764,7 @@
                 </a:solidFill>
                 <a:latin typeface="Calibri"/>
               </a:rPr>
-              <a:t>The EN + DIN config assigns every brace variant the same clearance, so variant comparison is degenerate under that jurisdiction.</a:t>
+              <a:t>The SB-001 config assigns every brace variant the same authored clearance, so variant comparison is degenerate under it.</a:t>
             </a:r>
           </a:p>
         </p:txBody>
@@ -10754,7 +10793,7 @@
                 </a:solidFill>
                 <a:latin typeface="Calibri"/>
               </a:rPr>
-              <a:t>EN 1998-1:2004+A2:2011</a:t>
+              <a:t>EN 1998-1:2004+A1:2013</a:t>
             </a:r>
           </a:p>
         </p:txBody>
@@ -10793,7 +10832,7 @@
                 </a:solidFill>
                 <a:latin typeface="Calibri"/>
               </a:rPr>
-              <a:t>Seismic restraint of non-structural elements</a:t>
+              <a:t>§4.3.5 (non-structural elements)</a:t>
             </a:r>
           </a:p>
         </p:txBody>
@@ -10832,7 +10871,7 @@
                 </a:solidFill>
                 <a:latin typeface="Calibri"/>
               </a:rPr>
-              <a:t>Clearance and spacing, EU config</a:t>
+              <a:t>Gives no MEP brace spacing or clearance</a:t>
             </a:r>
           </a:p>
         </p:txBody>
@@ -10917,7 +10956,7 @@
                 </a:solidFill>
                 <a:latin typeface="Calibri"/>
               </a:rPr>
-              <a:t>DIN 4149:2005-04</a:t>
+              <a:t>DIN EN 1998-1/NA:2018-10</a:t>
             </a:r>
           </a:p>
         </p:txBody>
@@ -10956,7 +10995,7 @@
                 </a:solidFill>
                 <a:latin typeface="Calibri"/>
               </a:rPr>
-              <a:t>German regional seismic provisions</a:t>
+              <a:t>German NA; DIN 4149 withdrawn</a:t>
             </a:r>
           </a:p>
         </p:txBody>
@@ -10995,7 +11034,7 @@
                 </a:solidFill>
                 <a:latin typeface="Calibri"/>
               </a:rPr>
-              <a:t>Merged into the EU jurisdiction config</a:t>
+              <a:t>Gives no MEP brace spacing or clearance</a:t>
             </a:r>
           </a:p>
         </p:txBody>
@@ -11080,7 +11119,7 @@
                 </a:solidFill>
                 <a:latin typeface="Calibri"/>
               </a:rPr>
-              <a:t>ASCE 7-22</a:t>
+              <a:t>FEMA E-74 (4th ed., December 2012)</a:t>
             </a:r>
           </a:p>
         </p:txBody>
@@ -11119,7 +11158,7 @@
                 </a:solidFill>
                 <a:latin typeface="Calibri"/>
               </a:rPr>
-              <a:t>US seismic design provisions</a:t>
+              <a:t>A guide, not a code</a:t>
             </a:r>
           </a:p>
         </p:txBody>
@@ -11158,7 +11197,7 @@
                 </a:solidFill>
                 <a:latin typeface="Calibri"/>
               </a:rPr>
-              <a:t>US fallback config, 457.2 mm</a:t>
+              <a:t>Duct area threshold, importance factors</a:t>
             </a:r>
           </a:p>
         </p:txBody>
@@ -11243,7 +11282,7 @@
                 </a:solidFill>
                 <a:latin typeface="Calibri"/>
               </a:rPr>
-              <a:t>NFPA 13</a:t>
+              <a:t>ASCE/SEI 7-10 §13.6</a:t>
             </a:r>
           </a:p>
         </p:txBody>
@@ -11282,7 +11321,7 @@
                 </a:solidFill>
                 <a:latin typeface="Calibri"/>
               </a:rPr>
-              <a:t>Sprinkler bracing and spacing</a:t>
+              <a:t>What FEMA E-74 defers to</a:t>
             </a:r>
           </a:p>
         </p:txBody>
@@ -11321,7 +11360,7 @@
                 </a:solidFill>
                 <a:latin typeface="Calibri"/>
               </a:rPr>
-              <a:t>US fallback config, fire systems</a:t>
+              <a:t>Upstream reference; not held</a:t>
             </a:r>
           </a:p>
         </p:txBody>
@@ -11686,7 +11725,7 @@
                 </a:solidFill>
                 <a:latin typeface="Calibri"/>
               </a:rPr>
-              <a:t>Configs are generated from the research summary by script and carry their own data-gap list, so every value is either sourced or flagged as absent.</a:t>
+              <a:t>There is one SB-001 config, not a jurisdictional pair. Neither EN 1998-1 nor the German National Annex dimensions MEP bracing; DIN 4149:2005-04 was withdrawn and replaced by DIN EN 1998-1:2010-12 with its National Annex; it is historical only.</a:t>
             </a:r>
           </a:p>
         </p:txBody>
@@ -11960,45 +11999,40 @@
       </p:sp>
       <p:sp>
         <p:nvSpPr>
-          <p:cNvPr id="8" name="Rectangle 7"/>
-          <p:cNvSpPr/>
-          <p:nvPr/>
-        </p:nvSpPr>
-        <p:spPr>
-          <a:xfrm>
-            <a:off x="228600" y="1234440"/>
-            <a:ext cx="8686800" cy="283464"/>
-          </a:xfrm>
-          <a:prstGeom prst="rect">
-            <a:avLst/>
-          </a:prstGeom>
-          <a:solidFill>
-            <a:srgbClr val="1F3864"/>
-          </a:solidFill>
-          <a:ln>
-            <a:noFill/>
-          </a:ln>
-          <a:effectLst/>
-        </p:spPr>
-        <p:style>
-          <a:lnRef idx="1">
-            <a:schemeClr val="accent1"/>
-          </a:lnRef>
-          <a:fillRef idx="3">
-            <a:schemeClr val="accent1"/>
-          </a:fillRef>
-          <a:effectRef idx="2">
-            <a:schemeClr val="accent1"/>
-          </a:effectRef>
-          <a:fontRef idx="minor">
-            <a:schemeClr val="lt1"/>
-          </a:fontRef>
-        </p:style>
-        <p:txBody>
-          <a:bodyPr rtlCol="0" anchor="ctr"/>
-          <a:lstStyle/>
-          <a:p>
-            <a:pPr algn="ctr"/>
+          <p:cNvPr id="8" name="TextBox 7"/>
+          <p:cNvSpPr txBox="1"/>
+          <p:nvPr/>
+        </p:nvSpPr>
+        <p:spPr>
+          <a:xfrm>
+            <a:off x="228600" y="1280160"/>
+            <a:ext cx="8686800" cy="640080"/>
+          </a:xfrm>
+          <a:prstGeom prst="rect">
+            <a:avLst/>
+          </a:prstGeom>
+          <a:noFill/>
+        </p:spPr>
+        <p:txBody>
+          <a:bodyPr wrap="square" anchor="t" lIns="0" rIns="0" tIns="0" bIns="0">
+            <a:spAutoFit/>
+          </a:bodyPr>
+          <a:lstStyle/>
+          <a:p>
+            <a:pPr algn="l">
+              <a:lnSpc>
+                <a:spcPct val="95000"/>
+              </a:lnSpc>
+            </a:pPr>
+            <a:r>
+              <a:rPr sz="1150" b="0">
+                <a:solidFill>
+                  <a:srgbClr val="374151"/>
+                </a:solidFill>
+                <a:latin typeface="Calibri"/>
+              </a:rPr>
+              <a:t>BIMGUARD SB-001 is a screening tool whose dimensional thresholds are authored calibration except where marked sourced, and it is not a substitute for design to ASCE/SEI 7-10 §13.6 or EN 1998-1.</a:t>
+            </a:r>
           </a:p>
         </p:txBody>
       </p:sp>
@@ -12010,33 +12044,33 @@
         </p:nvSpPr>
         <p:spPr>
           <a:xfrm>
-            <a:off x="292608" y="1280160"/>
-            <a:ext cx="2249424" cy="210311"/>
-          </a:xfrm>
-          <a:prstGeom prst="rect">
-            <a:avLst/>
-          </a:prstGeom>
-          <a:noFill/>
-        </p:spPr>
-        <p:txBody>
-          <a:bodyPr wrap="square" anchor="t" lIns="0" rIns="0" tIns="0" bIns="0">
-            <a:spAutoFit/>
-          </a:bodyPr>
-          <a:lstStyle/>
-          <a:p>
-            <a:pPr algn="l">
-              <a:lnSpc>
-                <a:spcPct val="100000"/>
-              </a:lnSpc>
-            </a:pPr>
-            <a:r>
-              <a:rPr sz="1050" b="1">
-                <a:solidFill>
-                  <a:srgbClr val="FFFFFF"/>
-                </a:solidFill>
-                <a:latin typeface="Calibri"/>
-              </a:rPr>
-              <a:t>Config field</a:t>
+            <a:off x="228600" y="2103120"/>
+            <a:ext cx="8686800" cy="640080"/>
+          </a:xfrm>
+          <a:prstGeom prst="rect">
+            <a:avLst/>
+          </a:prstGeom>
+          <a:noFill/>
+        </p:spPr>
+        <p:txBody>
+          <a:bodyPr wrap="square" anchor="t" lIns="0" rIns="0" tIns="0" bIns="0">
+            <a:spAutoFit/>
+          </a:bodyPr>
+          <a:lstStyle/>
+          <a:p>
+            <a:pPr algn="l">
+              <a:lnSpc>
+                <a:spcPct val="95000"/>
+              </a:lnSpc>
+            </a:pPr>
+            <a:r>
+              <a:rPr sz="1150" b="0">
+                <a:solidFill>
+                  <a:srgbClr val="374151"/>
+                </a:solidFill>
+                <a:latin typeface="Calibri"/>
+              </a:rPr>
+              <a:t>Every threshold carries a provenance block with a status: 3 sourced, 2 derived, 9 authored. FEMA E-74 (4th ed., December 2012) evidences the duct area threshold and the importance factors, and gives upstream brace spacing maxima that the authored calibration is deliberately tighter than. The remaining thresholds are authored, with no source held.</a:t>
             </a:r>
           </a:p>
         </p:txBody>
@@ -12044,1172 +12078,6 @@
       <p:sp>
         <p:nvSpPr>
           <p:cNvPr id="10" name="TextBox 9"/>
-          <p:cNvSpPr txBox="1"/>
-          <p:nvPr/>
-        </p:nvSpPr>
-        <p:spPr>
-          <a:xfrm>
-            <a:off x="2670048" y="1280160"/>
-            <a:ext cx="2066543" cy="210311"/>
-          </a:xfrm>
-          <a:prstGeom prst="rect">
-            <a:avLst/>
-          </a:prstGeom>
-          <a:noFill/>
-        </p:spPr>
-        <p:txBody>
-          <a:bodyPr wrap="square" anchor="t" lIns="0" rIns="0" tIns="0" bIns="0">
-            <a:spAutoFit/>
-          </a:bodyPr>
-          <a:lstStyle/>
-          <a:p>
-            <a:pPr algn="l">
-              <a:lnSpc>
-                <a:spcPct val="100000"/>
-              </a:lnSpc>
-            </a:pPr>
-            <a:r>
-              <a:rPr sz="1050" b="1">
-                <a:solidFill>
-                  <a:srgbClr val="FFFFFF"/>
-                </a:solidFill>
-                <a:latin typeface="Calibri"/>
-              </a:rPr>
-              <a:t>EN 1998-1 + DIN 4149</a:t>
-            </a:r>
-          </a:p>
-        </p:txBody>
-      </p:sp>
-      <p:sp>
-        <p:nvSpPr>
-          <p:cNvPr id="11" name="TextBox 10"/>
-          <p:cNvSpPr txBox="1"/>
-          <p:nvPr/>
-        </p:nvSpPr>
-        <p:spPr>
-          <a:xfrm>
-            <a:off x="4864608" y="1280160"/>
-            <a:ext cx="1975103" cy="210311"/>
-          </a:xfrm>
-          <a:prstGeom prst="rect">
-            <a:avLst/>
-          </a:prstGeom>
-          <a:noFill/>
-        </p:spPr>
-        <p:txBody>
-          <a:bodyPr wrap="square" anchor="t" lIns="0" rIns="0" tIns="0" bIns="0">
-            <a:spAutoFit/>
-          </a:bodyPr>
-          <a:lstStyle/>
-          <a:p>
-            <a:pPr algn="l">
-              <a:lnSpc>
-                <a:spcPct val="100000"/>
-              </a:lnSpc>
-            </a:pPr>
-            <a:r>
-              <a:rPr sz="1050" b="1">
-                <a:solidFill>
-                  <a:srgbClr val="FFFFFF"/>
-                </a:solidFill>
-                <a:latin typeface="Calibri"/>
-              </a:rPr>
-              <a:t>ASCE 7-22 + NFPA 13</a:t>
-            </a:r>
-          </a:p>
-        </p:txBody>
-      </p:sp>
-      <p:sp>
-        <p:nvSpPr>
-          <p:cNvPr id="12" name="TextBox 11"/>
-          <p:cNvSpPr txBox="1"/>
-          <p:nvPr/>
-        </p:nvSpPr>
-        <p:spPr>
-          <a:xfrm>
-            <a:off x="6967728" y="1280160"/>
-            <a:ext cx="1883664" cy="210311"/>
-          </a:xfrm>
-          <a:prstGeom prst="rect">
-            <a:avLst/>
-          </a:prstGeom>
-          <a:noFill/>
-        </p:spPr>
-        <p:txBody>
-          <a:bodyPr wrap="square" anchor="t" lIns="0" rIns="0" tIns="0" bIns="0">
-            <a:spAutoFit/>
-          </a:bodyPr>
-          <a:lstStyle/>
-          <a:p>
-            <a:pPr algn="l">
-              <a:lnSpc>
-                <a:spcPct val="100000"/>
-              </a:lnSpc>
-            </a:pPr>
-            <a:r>
-              <a:rPr sz="1050" b="1">
-                <a:solidFill>
-                  <a:srgbClr val="FFFFFF"/>
-                </a:solidFill>
-                <a:latin typeface="Calibri"/>
-              </a:rPr>
-              <a:t>Resolution rule</a:t>
-            </a:r>
-          </a:p>
-        </p:txBody>
-      </p:sp>
-      <p:sp>
-        <p:nvSpPr>
-          <p:cNvPr id="13" name="Rectangle 12"/>
-          <p:cNvSpPr/>
-          <p:nvPr/>
-        </p:nvSpPr>
-        <p:spPr>
-          <a:xfrm>
-            <a:off x="228600" y="1517904"/>
-            <a:ext cx="8686800" cy="283464"/>
-          </a:xfrm>
-          <a:prstGeom prst="rect">
-            <a:avLst/>
-          </a:prstGeom>
-          <a:solidFill>
-            <a:srgbClr val="FFFFFF"/>
-          </a:solidFill>
-          <a:ln w="9525">
-            <a:solidFill>
-              <a:srgbClr val="DEEAF1"/>
-            </a:solidFill>
-          </a:ln>
-          <a:effectLst/>
-        </p:spPr>
-        <p:style>
-          <a:lnRef idx="1">
-            <a:schemeClr val="accent1"/>
-          </a:lnRef>
-          <a:fillRef idx="3">
-            <a:schemeClr val="accent1"/>
-          </a:fillRef>
-          <a:effectRef idx="2">
-            <a:schemeClr val="accent1"/>
-          </a:effectRef>
-          <a:fontRef idx="minor">
-            <a:schemeClr val="lt1"/>
-          </a:fontRef>
-        </p:style>
-        <p:txBody>
-          <a:bodyPr rtlCol="0" anchor="ctr"/>
-          <a:lstStyle/>
-          <a:p>
-            <a:pPr algn="ctr"/>
-          </a:p>
-        </p:txBody>
-      </p:sp>
-      <p:sp>
-        <p:nvSpPr>
-          <p:cNvPr id="14" name="TextBox 13"/>
-          <p:cNvSpPr txBox="1"/>
-          <p:nvPr/>
-        </p:nvSpPr>
-        <p:spPr>
-          <a:xfrm>
-            <a:off x="292608" y="1563624"/>
-            <a:ext cx="2249424" cy="210311"/>
-          </a:xfrm>
-          <a:prstGeom prst="rect">
-            <a:avLst/>
-          </a:prstGeom>
-          <a:noFill/>
-        </p:spPr>
-        <p:txBody>
-          <a:bodyPr wrap="square" anchor="t" lIns="0" rIns="0" tIns="0" bIns="0">
-            <a:spAutoFit/>
-          </a:bodyPr>
-          <a:lstStyle/>
-          <a:p>
-            <a:pPr algn="l">
-              <a:lnSpc>
-                <a:spcPct val="100000"/>
-              </a:lnSpc>
-            </a:pPr>
-            <a:r>
-              <a:rPr sz="1100" b="0">
-                <a:solidFill>
-                  <a:srgbClr val="374151"/>
-                </a:solidFill>
-                <a:latin typeface="Calibri"/>
-              </a:rPr>
-              <a:t>base_from_structure_mm</a:t>
-            </a:r>
-          </a:p>
-        </p:txBody>
-      </p:sp>
-      <p:sp>
-        <p:nvSpPr>
-          <p:cNvPr id="15" name="TextBox 14"/>
-          <p:cNvSpPr txBox="1"/>
-          <p:nvPr/>
-        </p:nvSpPr>
-        <p:spPr>
-          <a:xfrm>
-            <a:off x="2670048" y="1563624"/>
-            <a:ext cx="2066543" cy="210311"/>
-          </a:xfrm>
-          <a:prstGeom prst="rect">
-            <a:avLst/>
-          </a:prstGeom>
-          <a:noFill/>
-        </p:spPr>
-        <p:txBody>
-          <a:bodyPr wrap="square" anchor="t" lIns="0" rIns="0" tIns="0" bIns="0">
-            <a:spAutoFit/>
-          </a:bodyPr>
-          <a:lstStyle/>
-          <a:p>
-            <a:pPr algn="l">
-              <a:lnSpc>
-                <a:spcPct val="100000"/>
-              </a:lnSpc>
-            </a:pPr>
-            <a:r>
-              <a:rPr sz="1100" b="0">
-                <a:solidFill>
-                  <a:srgbClr val="374151"/>
-                </a:solidFill>
-                <a:latin typeface="Calibri"/>
-              </a:rPr>
-              <a:t>200.0</a:t>
-            </a:r>
-          </a:p>
-        </p:txBody>
-      </p:sp>
-      <p:sp>
-        <p:nvSpPr>
-          <p:cNvPr id="16" name="TextBox 15"/>
-          <p:cNvSpPr txBox="1"/>
-          <p:nvPr/>
-        </p:nvSpPr>
-        <p:spPr>
-          <a:xfrm>
-            <a:off x="4864608" y="1563624"/>
-            <a:ext cx="1975103" cy="210311"/>
-          </a:xfrm>
-          <a:prstGeom prst="rect">
-            <a:avLst/>
-          </a:prstGeom>
-          <a:noFill/>
-        </p:spPr>
-        <p:txBody>
-          <a:bodyPr wrap="square" anchor="t" lIns="0" rIns="0" tIns="0" bIns="0">
-            <a:spAutoFit/>
-          </a:bodyPr>
-          <a:lstStyle/>
-          <a:p>
-            <a:pPr algn="l">
-              <a:lnSpc>
-                <a:spcPct val="100000"/>
-              </a:lnSpc>
-            </a:pPr>
-            <a:r>
-              <a:rPr sz="1100" b="0">
-                <a:solidFill>
-                  <a:srgbClr val="374151"/>
-                </a:solidFill>
-                <a:latin typeface="Calibri"/>
-              </a:rPr>
-              <a:t>457.2</a:t>
-            </a:r>
-          </a:p>
-        </p:txBody>
-      </p:sp>
-      <p:sp>
-        <p:nvSpPr>
-          <p:cNvPr id="17" name="TextBox 16"/>
-          <p:cNvSpPr txBox="1"/>
-          <p:nvPr/>
-        </p:nvSpPr>
-        <p:spPr>
-          <a:xfrm>
-            <a:off x="6967728" y="1563624"/>
-            <a:ext cx="1883664" cy="210311"/>
-          </a:xfrm>
-          <a:prstGeom prst="rect">
-            <a:avLst/>
-          </a:prstGeom>
-          <a:noFill/>
-        </p:spPr>
-        <p:txBody>
-          <a:bodyPr wrap="square" anchor="t" lIns="0" rIns="0" tIns="0" bIns="0">
-            <a:spAutoFit/>
-          </a:bodyPr>
-          <a:lstStyle/>
-          <a:p>
-            <a:pPr algn="l">
-              <a:lnSpc>
-                <a:spcPct val="100000"/>
-              </a:lnSpc>
-            </a:pPr>
-            <a:r>
-              <a:rPr sz="1100" b="0">
-                <a:solidFill>
-                  <a:srgbClr val="374151"/>
-                </a:solidFill>
-                <a:latin typeface="Calibri"/>
-              </a:rPr>
-              <a:t>Larger clearance governs</a:t>
-            </a:r>
-          </a:p>
-        </p:txBody>
-      </p:sp>
-      <p:sp>
-        <p:nvSpPr>
-          <p:cNvPr id="18" name="Rectangle 17"/>
-          <p:cNvSpPr/>
-          <p:nvPr/>
-        </p:nvSpPr>
-        <p:spPr>
-          <a:xfrm>
-            <a:off x="228600" y="1801368"/>
-            <a:ext cx="8686800" cy="283464"/>
-          </a:xfrm>
-          <a:prstGeom prst="rect">
-            <a:avLst/>
-          </a:prstGeom>
-          <a:solidFill>
-            <a:srgbClr val="F3F6F9"/>
-          </a:solidFill>
-          <a:ln w="9525">
-            <a:solidFill>
-              <a:srgbClr val="DEEAF1"/>
-            </a:solidFill>
-          </a:ln>
-          <a:effectLst/>
-        </p:spPr>
-        <p:style>
-          <a:lnRef idx="1">
-            <a:schemeClr val="accent1"/>
-          </a:lnRef>
-          <a:fillRef idx="3">
-            <a:schemeClr val="accent1"/>
-          </a:fillRef>
-          <a:effectRef idx="2">
-            <a:schemeClr val="accent1"/>
-          </a:effectRef>
-          <a:fontRef idx="minor">
-            <a:schemeClr val="lt1"/>
-          </a:fontRef>
-        </p:style>
-        <p:txBody>
-          <a:bodyPr rtlCol="0" anchor="ctr"/>
-          <a:lstStyle/>
-          <a:p>
-            <a:pPr algn="ctr"/>
-          </a:p>
-        </p:txBody>
-      </p:sp>
-      <p:sp>
-        <p:nvSpPr>
-          <p:cNvPr id="19" name="TextBox 18"/>
-          <p:cNvSpPr txBox="1"/>
-          <p:nvPr/>
-        </p:nvSpPr>
-        <p:spPr>
-          <a:xfrm>
-            <a:off x="292608" y="1847088"/>
-            <a:ext cx="2249424" cy="210311"/>
-          </a:xfrm>
-          <a:prstGeom prst="rect">
-            <a:avLst/>
-          </a:prstGeom>
-          <a:noFill/>
-        </p:spPr>
-        <p:txBody>
-          <a:bodyPr wrap="square" anchor="t" lIns="0" rIns="0" tIns="0" bIns="0">
-            <a:spAutoFit/>
-          </a:bodyPr>
-          <a:lstStyle/>
-          <a:p>
-            <a:pPr algn="l">
-              <a:lnSpc>
-                <a:spcPct val="100000"/>
-              </a:lnSpc>
-            </a:pPr>
-            <a:r>
-              <a:rPr sz="1100" b="0">
-                <a:solidFill>
-                  <a:srgbClr val="374151"/>
-                </a:solidFill>
-                <a:latin typeface="Calibri"/>
-              </a:rPr>
-              <a:t>spacing_transverse_m</a:t>
-            </a:r>
-          </a:p>
-        </p:txBody>
-      </p:sp>
-      <p:sp>
-        <p:nvSpPr>
-          <p:cNvPr id="20" name="TextBox 19"/>
-          <p:cNvSpPr txBox="1"/>
-          <p:nvPr/>
-        </p:nvSpPr>
-        <p:spPr>
-          <a:xfrm>
-            <a:off x="2670048" y="1847088"/>
-            <a:ext cx="2066543" cy="210311"/>
-          </a:xfrm>
-          <a:prstGeom prst="rect">
-            <a:avLst/>
-          </a:prstGeom>
-          <a:noFill/>
-        </p:spPr>
-        <p:txBody>
-          <a:bodyPr wrap="square" anchor="t" lIns="0" rIns="0" tIns="0" bIns="0">
-            <a:spAutoFit/>
-          </a:bodyPr>
-          <a:lstStyle/>
-          <a:p>
-            <a:pPr algn="l">
-              <a:lnSpc>
-                <a:spcPct val="100000"/>
-              </a:lnSpc>
-            </a:pPr>
-            <a:r>
-              <a:rPr sz="1100" b="0">
-                <a:solidFill>
-                  <a:srgbClr val="374151"/>
-                </a:solidFill>
-                <a:latin typeface="Calibri"/>
-              </a:rPr>
-              <a:t>1.0</a:t>
-            </a:r>
-          </a:p>
-        </p:txBody>
-      </p:sp>
-      <p:sp>
-        <p:nvSpPr>
-          <p:cNvPr id="21" name="TextBox 20"/>
-          <p:cNvSpPr txBox="1"/>
-          <p:nvPr/>
-        </p:nvSpPr>
-        <p:spPr>
-          <a:xfrm>
-            <a:off x="4864608" y="1847088"/>
-            <a:ext cx="1975103" cy="210311"/>
-          </a:xfrm>
-          <a:prstGeom prst="rect">
-            <a:avLst/>
-          </a:prstGeom>
-          <a:noFill/>
-        </p:spPr>
-        <p:txBody>
-          <a:bodyPr wrap="square" anchor="t" lIns="0" rIns="0" tIns="0" bIns="0">
-            <a:spAutoFit/>
-          </a:bodyPr>
-          <a:lstStyle/>
-          <a:p>
-            <a:pPr algn="l">
-              <a:lnSpc>
-                <a:spcPct val="100000"/>
-              </a:lnSpc>
-            </a:pPr>
-            <a:r>
-              <a:rPr sz="1100" b="0">
-                <a:solidFill>
-                  <a:srgbClr val="374151"/>
-                </a:solidFill>
-                <a:latin typeface="Calibri"/>
-              </a:rPr>
-              <a:t>1.016</a:t>
-            </a:r>
-          </a:p>
-        </p:txBody>
-      </p:sp>
-      <p:sp>
-        <p:nvSpPr>
-          <p:cNvPr id="22" name="TextBox 21"/>
-          <p:cNvSpPr txBox="1"/>
-          <p:nvPr/>
-        </p:nvSpPr>
-        <p:spPr>
-          <a:xfrm>
-            <a:off x="6967728" y="1847088"/>
-            <a:ext cx="1883664" cy="210311"/>
-          </a:xfrm>
-          <a:prstGeom prst="rect">
-            <a:avLst/>
-          </a:prstGeom>
-          <a:noFill/>
-        </p:spPr>
-        <p:txBody>
-          <a:bodyPr wrap="square" anchor="t" lIns="0" rIns="0" tIns="0" bIns="0">
-            <a:spAutoFit/>
-          </a:bodyPr>
-          <a:lstStyle/>
-          <a:p>
-            <a:pPr algn="l">
-              <a:lnSpc>
-                <a:spcPct val="100000"/>
-              </a:lnSpc>
-            </a:pPr>
-            <a:r>
-              <a:rPr sz="1100" b="0">
-                <a:solidFill>
-                  <a:srgbClr val="374151"/>
-                </a:solidFill>
-                <a:latin typeface="Calibri"/>
-              </a:rPr>
-              <a:t>Tighter spacing governs</a:t>
-            </a:r>
-          </a:p>
-        </p:txBody>
-      </p:sp>
-      <p:sp>
-        <p:nvSpPr>
-          <p:cNvPr id="23" name="Rectangle 22"/>
-          <p:cNvSpPr/>
-          <p:nvPr/>
-        </p:nvSpPr>
-        <p:spPr>
-          <a:xfrm>
-            <a:off x="228600" y="2084832"/>
-            <a:ext cx="8686800" cy="283464"/>
-          </a:xfrm>
-          <a:prstGeom prst="rect">
-            <a:avLst/>
-          </a:prstGeom>
-          <a:solidFill>
-            <a:srgbClr val="FFFFFF"/>
-          </a:solidFill>
-          <a:ln w="9525">
-            <a:solidFill>
-              <a:srgbClr val="DEEAF1"/>
-            </a:solidFill>
-          </a:ln>
-          <a:effectLst/>
-        </p:spPr>
-        <p:style>
-          <a:lnRef idx="1">
-            <a:schemeClr val="accent1"/>
-          </a:lnRef>
-          <a:fillRef idx="3">
-            <a:schemeClr val="accent1"/>
-          </a:fillRef>
-          <a:effectRef idx="2">
-            <a:schemeClr val="accent1"/>
-          </a:effectRef>
-          <a:fontRef idx="minor">
-            <a:schemeClr val="lt1"/>
-          </a:fontRef>
-        </p:style>
-        <p:txBody>
-          <a:bodyPr rtlCol="0" anchor="ctr"/>
-          <a:lstStyle/>
-          <a:p>
-            <a:pPr algn="ctr"/>
-          </a:p>
-        </p:txBody>
-      </p:sp>
-      <p:sp>
-        <p:nvSpPr>
-          <p:cNvPr id="24" name="TextBox 23"/>
-          <p:cNvSpPr txBox="1"/>
-          <p:nvPr/>
-        </p:nvSpPr>
-        <p:spPr>
-          <a:xfrm>
-            <a:off x="292608" y="2130552"/>
-            <a:ext cx="2249424" cy="210311"/>
-          </a:xfrm>
-          <a:prstGeom prst="rect">
-            <a:avLst/>
-          </a:prstGeom>
-          <a:noFill/>
-        </p:spPr>
-        <p:txBody>
-          <a:bodyPr wrap="square" anchor="t" lIns="0" rIns="0" tIns="0" bIns="0">
-            <a:spAutoFit/>
-          </a:bodyPr>
-          <a:lstStyle/>
-          <a:p>
-            <a:pPr algn="l">
-              <a:lnSpc>
-                <a:spcPct val="100000"/>
-              </a:lnSpc>
-            </a:pPr>
-            <a:r>
-              <a:rPr sz="1100" b="0">
-                <a:solidFill>
-                  <a:srgbClr val="374151"/>
-                </a:solidFill>
-                <a:latin typeface="Calibri"/>
-              </a:rPr>
-              <a:t>pipe_diameter_mm</a:t>
-            </a:r>
-          </a:p>
-        </p:txBody>
-      </p:sp>
-      <p:sp>
-        <p:nvSpPr>
-          <p:cNvPr id="25" name="TextBox 24"/>
-          <p:cNvSpPr txBox="1"/>
-          <p:nvPr/>
-        </p:nvSpPr>
-        <p:spPr>
-          <a:xfrm>
-            <a:off x="2670048" y="2130552"/>
-            <a:ext cx="2066543" cy="210311"/>
-          </a:xfrm>
-          <a:prstGeom prst="rect">
-            <a:avLst/>
-          </a:prstGeom>
-          <a:noFill/>
-        </p:spPr>
-        <p:txBody>
-          <a:bodyPr wrap="square" anchor="t" lIns="0" rIns="0" tIns="0" bIns="0">
-            <a:spAutoFit/>
-          </a:bodyPr>
-          <a:lstStyle/>
-          <a:p>
-            <a:pPr algn="l">
-              <a:lnSpc>
-                <a:spcPct val="100000"/>
-              </a:lnSpc>
-            </a:pPr>
-            <a:r>
-              <a:rPr sz="1100" b="0">
-                <a:solidFill>
-                  <a:srgbClr val="374151"/>
-                </a:solidFill>
-                <a:latin typeface="Calibri"/>
-              </a:rPr>
-              <a:t>63.0</a:t>
-            </a:r>
-          </a:p>
-        </p:txBody>
-      </p:sp>
-      <p:sp>
-        <p:nvSpPr>
-          <p:cNvPr id="26" name="TextBox 25"/>
-          <p:cNvSpPr txBox="1"/>
-          <p:nvPr/>
-        </p:nvSpPr>
-        <p:spPr>
-          <a:xfrm>
-            <a:off x="4864608" y="2130552"/>
-            <a:ext cx="1975103" cy="210311"/>
-          </a:xfrm>
-          <a:prstGeom prst="rect">
-            <a:avLst/>
-          </a:prstGeom>
-          <a:noFill/>
-        </p:spPr>
-        <p:txBody>
-          <a:bodyPr wrap="square" anchor="t" lIns="0" rIns="0" tIns="0" bIns="0">
-            <a:spAutoFit/>
-          </a:bodyPr>
-          <a:lstStyle/>
-          <a:p>
-            <a:pPr algn="l">
-              <a:lnSpc>
-                <a:spcPct val="100000"/>
-              </a:lnSpc>
-            </a:pPr>
-            <a:r>
-              <a:rPr sz="1100" b="0">
-                <a:solidFill>
-                  <a:srgbClr val="374151"/>
-                </a:solidFill>
-                <a:latin typeface="Calibri"/>
-              </a:rPr>
-              <a:t>63.5</a:t>
-            </a:r>
-          </a:p>
-        </p:txBody>
-      </p:sp>
-      <p:sp>
-        <p:nvSpPr>
-          <p:cNvPr id="27" name="TextBox 26"/>
-          <p:cNvSpPr txBox="1"/>
-          <p:nvPr/>
-        </p:nvSpPr>
-        <p:spPr>
-          <a:xfrm>
-            <a:off x="6967728" y="2130552"/>
-            <a:ext cx="1883664" cy="210311"/>
-          </a:xfrm>
-          <a:prstGeom prst="rect">
-            <a:avLst/>
-          </a:prstGeom>
-          <a:noFill/>
-        </p:spPr>
-        <p:txBody>
-          <a:bodyPr wrap="square" anchor="t" lIns="0" rIns="0" tIns="0" bIns="0">
-            <a:spAutoFit/>
-          </a:bodyPr>
-          <a:lstStyle/>
-          <a:p>
-            <a:pPr algn="l">
-              <a:lnSpc>
-                <a:spcPct val="100000"/>
-              </a:lnSpc>
-            </a:pPr>
-            <a:r>
-              <a:rPr sz="1100" b="0">
-                <a:solidFill>
-                  <a:srgbClr val="374151"/>
-                </a:solidFill>
-                <a:latin typeface="Calibri"/>
-              </a:rPr>
-              <a:t>Lower threshold governs</a:t>
-            </a:r>
-          </a:p>
-        </p:txBody>
-      </p:sp>
-      <p:sp>
-        <p:nvSpPr>
-          <p:cNvPr id="28" name="Rectangle 27"/>
-          <p:cNvSpPr/>
-          <p:nvPr/>
-        </p:nvSpPr>
-        <p:spPr>
-          <a:xfrm>
-            <a:off x="228600" y="2368296"/>
-            <a:ext cx="8686800" cy="283464"/>
-          </a:xfrm>
-          <a:prstGeom prst="rect">
-            <a:avLst/>
-          </a:prstGeom>
-          <a:solidFill>
-            <a:srgbClr val="F3F6F9"/>
-          </a:solidFill>
-          <a:ln w="9525">
-            <a:solidFill>
-              <a:srgbClr val="DEEAF1"/>
-            </a:solidFill>
-          </a:ln>
-          <a:effectLst/>
-        </p:spPr>
-        <p:style>
-          <a:lnRef idx="1">
-            <a:schemeClr val="accent1"/>
-          </a:lnRef>
-          <a:fillRef idx="3">
-            <a:schemeClr val="accent1"/>
-          </a:fillRef>
-          <a:effectRef idx="2">
-            <a:schemeClr val="accent1"/>
-          </a:effectRef>
-          <a:fontRef idx="minor">
-            <a:schemeClr val="lt1"/>
-          </a:fontRef>
-        </p:style>
-        <p:txBody>
-          <a:bodyPr rtlCol="0" anchor="ctr"/>
-          <a:lstStyle/>
-          <a:p>
-            <a:pPr algn="ctr"/>
-          </a:p>
-        </p:txBody>
-      </p:sp>
-      <p:sp>
-        <p:nvSpPr>
-          <p:cNvPr id="29" name="TextBox 28"/>
-          <p:cNvSpPr txBox="1"/>
-          <p:nvPr/>
-        </p:nvSpPr>
-        <p:spPr>
-          <a:xfrm>
-            <a:off x="292608" y="2414015"/>
-            <a:ext cx="2249424" cy="210311"/>
-          </a:xfrm>
-          <a:prstGeom prst="rect">
-            <a:avLst/>
-          </a:prstGeom>
-          <a:noFill/>
-        </p:spPr>
-        <p:txBody>
-          <a:bodyPr wrap="square" anchor="t" lIns="0" rIns="0" tIns="0" bIns="0">
-            <a:spAutoFit/>
-          </a:bodyPr>
-          <a:lstStyle/>
-          <a:p>
-            <a:pPr algn="l">
-              <a:lnSpc>
-                <a:spcPct val="100000"/>
-              </a:lnSpc>
-            </a:pPr>
-            <a:r>
-              <a:rPr sz="1100" b="0">
-                <a:solidFill>
-                  <a:srgbClr val="374151"/>
-                </a:solidFill>
-                <a:latin typeface="Calibri"/>
-              </a:rPr>
-              <a:t>angle range (deg)</a:t>
-            </a:r>
-          </a:p>
-        </p:txBody>
-      </p:sp>
-      <p:sp>
-        <p:nvSpPr>
-          <p:cNvPr id="30" name="TextBox 29"/>
-          <p:cNvSpPr txBox="1"/>
-          <p:nvPr/>
-        </p:nvSpPr>
-        <p:spPr>
-          <a:xfrm>
-            <a:off x="2670048" y="2414015"/>
-            <a:ext cx="2066543" cy="210311"/>
-          </a:xfrm>
-          <a:prstGeom prst="rect">
-            <a:avLst/>
-          </a:prstGeom>
-          <a:noFill/>
-        </p:spPr>
-        <p:txBody>
-          <a:bodyPr wrap="square" anchor="t" lIns="0" rIns="0" tIns="0" bIns="0">
-            <a:spAutoFit/>
-          </a:bodyPr>
-          <a:lstStyle/>
-          <a:p>
-            <a:pPr algn="l">
-              <a:lnSpc>
-                <a:spcPct val="100000"/>
-              </a:lnSpc>
-            </a:pPr>
-            <a:r>
-              <a:rPr sz="1100" b="0">
-                <a:solidFill>
-                  <a:srgbClr val="374151"/>
-                </a:solidFill>
-                <a:latin typeface="Calibri"/>
-              </a:rPr>
-              <a:t>40 – 65</a:t>
-            </a:r>
-          </a:p>
-        </p:txBody>
-      </p:sp>
-      <p:sp>
-        <p:nvSpPr>
-          <p:cNvPr id="31" name="TextBox 30"/>
-          <p:cNvSpPr txBox="1"/>
-          <p:nvPr/>
-        </p:nvSpPr>
-        <p:spPr>
-          <a:xfrm>
-            <a:off x="4864608" y="2414015"/>
-            <a:ext cx="1975103" cy="210311"/>
-          </a:xfrm>
-          <a:prstGeom prst="rect">
-            <a:avLst/>
-          </a:prstGeom>
-          <a:noFill/>
-        </p:spPr>
-        <p:txBody>
-          <a:bodyPr wrap="square" anchor="t" lIns="0" rIns="0" tIns="0" bIns="0">
-            <a:spAutoFit/>
-          </a:bodyPr>
-          <a:lstStyle/>
-          <a:p>
-            <a:pPr algn="l">
-              <a:lnSpc>
-                <a:spcPct val="100000"/>
-              </a:lnSpc>
-            </a:pPr>
-            <a:r>
-              <a:rPr sz="1100" b="0">
-                <a:solidFill>
-                  <a:srgbClr val="374151"/>
-                </a:solidFill>
-                <a:latin typeface="Calibri"/>
-              </a:rPr>
-              <a:t>30 – 60</a:t>
-            </a:r>
-          </a:p>
-        </p:txBody>
-      </p:sp>
-      <p:sp>
-        <p:nvSpPr>
-          <p:cNvPr id="32" name="TextBox 31"/>
-          <p:cNvSpPr txBox="1"/>
-          <p:nvPr/>
-        </p:nvSpPr>
-        <p:spPr>
-          <a:xfrm>
-            <a:off x="6967728" y="2414015"/>
-            <a:ext cx="1883664" cy="210311"/>
-          </a:xfrm>
-          <a:prstGeom prst="rect">
-            <a:avLst/>
-          </a:prstGeom>
-          <a:noFill/>
-        </p:spPr>
-        <p:txBody>
-          <a:bodyPr wrap="square" anchor="t" lIns="0" rIns="0" tIns="0" bIns="0">
-            <a:spAutoFit/>
-          </a:bodyPr>
-          <a:lstStyle/>
-          <a:p>
-            <a:pPr algn="l">
-              <a:lnSpc>
-                <a:spcPct val="100000"/>
-              </a:lnSpc>
-            </a:pPr>
-            <a:r>
-              <a:rPr sz="1100" b="0">
-                <a:solidFill>
-                  <a:srgbClr val="374151"/>
-                </a:solidFill>
-                <a:latin typeface="Calibri"/>
-              </a:rPr>
-              <a:t>Intersection of both ranges</a:t>
-            </a:r>
-          </a:p>
-        </p:txBody>
-      </p:sp>
-      <p:sp>
-        <p:nvSpPr>
-          <p:cNvPr id="33" name="Rectangle 32"/>
-          <p:cNvSpPr/>
-          <p:nvPr/>
-        </p:nvSpPr>
-        <p:spPr>
-          <a:xfrm>
-            <a:off x="228600" y="2651760"/>
-            <a:ext cx="8686800" cy="283464"/>
-          </a:xfrm>
-          <a:prstGeom prst="rect">
-            <a:avLst/>
-          </a:prstGeom>
-          <a:solidFill>
-            <a:srgbClr val="FFFFFF"/>
-          </a:solidFill>
-          <a:ln w="9525">
-            <a:solidFill>
-              <a:srgbClr val="DEEAF1"/>
-            </a:solidFill>
-          </a:ln>
-          <a:effectLst/>
-        </p:spPr>
-        <p:style>
-          <a:lnRef idx="1">
-            <a:schemeClr val="accent1"/>
-          </a:lnRef>
-          <a:fillRef idx="3">
-            <a:schemeClr val="accent1"/>
-          </a:fillRef>
-          <a:effectRef idx="2">
-            <a:schemeClr val="accent1"/>
-          </a:effectRef>
-          <a:fontRef idx="minor">
-            <a:schemeClr val="lt1"/>
-          </a:fontRef>
-        </p:style>
-        <p:txBody>
-          <a:bodyPr rtlCol="0" anchor="ctr"/>
-          <a:lstStyle/>
-          <a:p>
-            <a:pPr algn="ctr"/>
-          </a:p>
-        </p:txBody>
-      </p:sp>
-      <p:sp>
-        <p:nvSpPr>
-          <p:cNvPr id="34" name="TextBox 33"/>
-          <p:cNvSpPr txBox="1"/>
-          <p:nvPr/>
-        </p:nvSpPr>
-        <p:spPr>
-          <a:xfrm>
-            <a:off x="292608" y="2697480"/>
-            <a:ext cx="2249424" cy="210311"/>
-          </a:xfrm>
-          <a:prstGeom prst="rect">
-            <a:avLst/>
-          </a:prstGeom>
-          <a:noFill/>
-        </p:spPr>
-        <p:txBody>
-          <a:bodyPr wrap="square" anchor="t" lIns="0" rIns="0" tIns="0" bIns="0">
-            <a:spAutoFit/>
-          </a:bodyPr>
-          <a:lstStyle/>
-          <a:p>
-            <a:pPr algn="l">
-              <a:lnSpc>
-                <a:spcPct val="100000"/>
-              </a:lnSpc>
-            </a:pPr>
-            <a:r>
-              <a:rPr sz="1100" b="0">
-                <a:solidFill>
-                  <a:srgbClr val="374151"/>
-                </a:solidFill>
-                <a:latin typeface="Calibri"/>
-              </a:rPr>
-              <a:t>hospital_addition_mm</a:t>
-            </a:r>
-          </a:p>
-        </p:txBody>
-      </p:sp>
-      <p:sp>
-        <p:nvSpPr>
-          <p:cNvPr id="35" name="TextBox 34"/>
-          <p:cNvSpPr txBox="1"/>
-          <p:nvPr/>
-        </p:nvSpPr>
-        <p:spPr>
-          <a:xfrm>
-            <a:off x="2670048" y="2697480"/>
-            <a:ext cx="2066543" cy="210311"/>
-          </a:xfrm>
-          <a:prstGeom prst="rect">
-            <a:avLst/>
-          </a:prstGeom>
-          <a:noFill/>
-        </p:spPr>
-        <p:txBody>
-          <a:bodyPr wrap="square" anchor="t" lIns="0" rIns="0" tIns="0" bIns="0">
-            <a:spAutoFit/>
-          </a:bodyPr>
-          <a:lstStyle/>
-          <a:p>
-            <a:pPr algn="l">
-              <a:lnSpc>
-                <a:spcPct val="100000"/>
-              </a:lnSpc>
-            </a:pPr>
-            <a:r>
-              <a:rPr sz="1100" b="0">
-                <a:solidFill>
-                  <a:srgbClr val="A32D2D"/>
-                </a:solidFill>
-                <a:latin typeface="Calibri"/>
-              </a:rPr>
-              <a:t>0 — data gap</a:t>
-            </a:r>
-          </a:p>
-        </p:txBody>
-      </p:sp>
-      <p:sp>
-        <p:nvSpPr>
-          <p:cNvPr id="36" name="TextBox 35"/>
-          <p:cNvSpPr txBox="1"/>
-          <p:nvPr/>
-        </p:nvSpPr>
-        <p:spPr>
-          <a:xfrm>
-            <a:off x="4864608" y="2697480"/>
-            <a:ext cx="1975103" cy="210311"/>
-          </a:xfrm>
-          <a:prstGeom prst="rect">
-            <a:avLst/>
-          </a:prstGeom>
-          <a:noFill/>
-        </p:spPr>
-        <p:txBody>
-          <a:bodyPr wrap="square" anchor="t" lIns="0" rIns="0" tIns="0" bIns="0">
-            <a:spAutoFit/>
-          </a:bodyPr>
-          <a:lstStyle/>
-          <a:p>
-            <a:pPr algn="l">
-              <a:lnSpc>
-                <a:spcPct val="100000"/>
-              </a:lnSpc>
-            </a:pPr>
-            <a:r>
-              <a:rPr sz="1100" b="0">
-                <a:solidFill>
-                  <a:srgbClr val="A32D2D"/>
-                </a:solidFill>
-                <a:latin typeface="Calibri"/>
-              </a:rPr>
-              <a:t>0 — data gap</a:t>
-            </a:r>
-          </a:p>
-        </p:txBody>
-      </p:sp>
-      <p:sp>
-        <p:nvSpPr>
-          <p:cNvPr id="37" name="TextBox 36"/>
-          <p:cNvSpPr txBox="1"/>
-          <p:nvPr/>
-        </p:nvSpPr>
-        <p:spPr>
-          <a:xfrm>
-            <a:off x="6967728" y="2697480"/>
-            <a:ext cx="1883664" cy="210311"/>
-          </a:xfrm>
-          <a:prstGeom prst="rect">
-            <a:avLst/>
-          </a:prstGeom>
-          <a:noFill/>
-        </p:spPr>
-        <p:txBody>
-          <a:bodyPr wrap="square" anchor="t" lIns="0" rIns="0" tIns="0" bIns="0">
-            <a:spAutoFit/>
-          </a:bodyPr>
-          <a:lstStyle/>
-          <a:p>
-            <a:pPr algn="l">
-              <a:lnSpc>
-                <a:spcPct val="100000"/>
-              </a:lnSpc>
-            </a:pPr>
-            <a:r>
-              <a:rPr sz="1100" b="0">
-                <a:solidFill>
-                  <a:srgbClr val="374151"/>
-                </a:solidFill>
-                <a:latin typeface="Calibri"/>
-              </a:rPr>
-              <a:t>Absent from source research</a:t>
-            </a:r>
-          </a:p>
-        </p:txBody>
-      </p:sp>
-      <p:sp>
-        <p:nvSpPr>
-          <p:cNvPr id="38" name="TextBox 37"/>
-          <p:cNvSpPr txBox="1"/>
-          <p:nvPr/>
-        </p:nvSpPr>
-        <p:spPr>
-          <a:xfrm>
-            <a:off x="228600" y="3017520"/>
-            <a:ext cx="8686800" cy="640080"/>
-          </a:xfrm>
-          <a:prstGeom prst="rect">
-            <a:avLst/>
-          </a:prstGeom>
-          <a:noFill/>
-        </p:spPr>
-        <p:txBody>
-          <a:bodyPr wrap="square" anchor="t" lIns="0" rIns="0" tIns="0" bIns="0">
-            <a:spAutoFit/>
-          </a:bodyPr>
-          <a:lstStyle/>
-          <a:p>
-            <a:pPr algn="l">
-              <a:lnSpc>
-                <a:spcPct val="95000"/>
-              </a:lnSpc>
-            </a:pPr>
-            <a:r>
-              <a:rPr sz="1150" b="0">
-                <a:solidFill>
-                  <a:srgbClr val="374151"/>
-                </a:solidFill>
-                <a:latin typeface="Calibri"/>
-              </a:rPr>
-              <a:t>Configs are generated from the standards research by script, never hand-edited. Each carries its own data-gap list, so a value that the source did not supply is flagged rather than invented — the hospital clearance addition above is recorded as absent rather than guessed.</a:t>
-            </a:r>
-          </a:p>
-        </p:txBody>
-      </p:sp>
-      <p:sp>
-        <p:nvSpPr>
-          <p:cNvPr id="39" name="TextBox 38"/>
           <p:cNvSpPr txBox="1"/>
           <p:nvPr/>
         </p:nvSpPr>
@@ -18485,7 +17353,7 @@
                 </a:solidFill>
                 <a:latin typeface="Calibri"/>
               </a:rPr>
-              <a:t>Halo generation and clash detection are deterministic, schema-independent and scale to the largest models in the corpus. What the corpus cannot yet support is brace-family differentiation, because the jurisdiction data does not distinguish clearance by hardware. The method is validated; that particular comparison is not.</a:t>
+              <a:t>Halo generation and clash detection are deterministic, schema-independent and scale to the largest models in the corpus. What the corpus cannot yet support is brace-family differentiation, because the SB-001 config does not distinguish clearance by hardware. The method is validated; that particular comparison is not.</a:t>
             </a:r>
           </a:p>
         </p:txBody>
@@ -19256,7 +18124,7 @@
                 </a:solidFill>
                 <a:latin typeface="Calibri"/>
               </a:rPr>
-              <a:t>A 2× clearance change moves total clashes by 2× and Critical count in the opposite direction. Jurisdiction selection is the most consequential input.</a:t>
+              <a:t>A 2× clearance change moves total clashes by 2× and Critical count in the opposite direction. The clearance value is the most consequential input.</a:t>
             </a:r>
           </a:p>
         </p:txBody>
@@ -20206,7 +19074,7 @@
                 </a:solidFill>
                 <a:latin typeface="Calibri"/>
               </a:rPr>
-              <a:t>EN 1998-1:2020 + DIN 4149:2022 resolve to 200 mm base; ASCE 7-22 + NFPA 13 resolve to 457.2 mm (18 in).</a:t>
+              <a:t>The shipped SB-001 config sets a 200 mm base: authored screening calibration, not a code value. No code or guide held gives a braced-service clearance.</a:t>
             </a:r>
           </a:p>
         </p:txBody>
@@ -22548,7 +21416,7 @@
                 </a:solidFill>
                 <a:latin typeface="Calibri"/>
               </a:rPr>
-              <a:t>Deterministic, and traceable to a clause</a:t>
+              <a:t>Deterministic, and traceable to its config rule</a:t>
             </a:r>
           </a:p>
         </p:txBody>
@@ -23179,7 +22047,7 @@
                 </a:solidFill>
                 <a:latin typeface="Calibri"/>
               </a:rPr>
-              <a:t>Each HaloVolume carries the rule variant, the clearance applied and the flags that modified it, so a volume can be traced back to the standard clause.</a:t>
+              <a:t>Each HaloVolume carries the rule variant, the clearance applied and the flags that modified it, so a volume can be traced back to the config rule and its provenance status.</a:t>
             </a:r>
           </a:p>
         </p:txBody>
@@ -26987,7 +25855,7 @@
                 </a:solidFill>
                 <a:latin typeface="Calibri"/>
               </a:rPr>
-              <a:t>All four variants share one clearance because the EN 1998-1 + DIN 4149 research does not differentiate clearance by brace hardware — a documented data gap in that config, not a property of the building. Where a jurisdiction does differentiate, the comparison separates and the smallest-footprint family wins.</a:t>
+              <a:t>All four brace-type variants in the SB-001 config share one authored clearance; no source held distinguishes them. That is a gap in the config, not a property of the building. Where a config does differentiate, the comparison separates and the smallest-footprint family wins.</a:t>
             </a:r>
           </a:p>
         </p:txBody>
@@ -27026,7 +25894,7 @@
                 </a:solidFill>
                 <a:latin typeface="Calibri"/>
               </a:rPr>
-              <a:t>This is the honest form of the comparison: the method distinguishes families; this jurisdiction's data does not yet let it.</a:t>
+              <a:t>This is the honest form of the comparison: the method distinguishes families; the SB-001 config does not yet let it.</a:t>
             </a:r>
           </a:p>
         </p:txBody>

</xml_diff>

<commit_message>
fix(decks): stop the formula boxes overlapping on deck B slide 3
On "How the clearance envelope is derived", the first formula's caption ran into
the second formula box, which started at y=2.50 immediately below it. The second
formula moves to y=2.80 and the body note to y=4.15, so the caption, both boxes
and the note each have their own space. Text and numbers are unchanged; deck B
is rebuilt.
</commit_message>
<xml_diff>
--- a/docs/Presentation-2026-May/BIMGUARD_FMP_B_Blue_Halo.pptx
+++ b/docs/Presentation-2026-May/BIMGUARD_FMP_B_Blue_Halo.pptx
@@ -18963,7 +18963,7 @@
         </p:nvSpPr>
         <p:spPr>
           <a:xfrm>
-            <a:off x="228600" y="2286000"/>
+            <a:off x="228600" y="2560320"/>
             <a:ext cx="8686800" cy="731520"/>
           </a:xfrm>
           <a:prstGeom prst="rect">
@@ -19009,7 +19009,7 @@
         </p:nvSpPr>
         <p:spPr>
           <a:xfrm>
-            <a:off x="320040" y="2450592"/>
+            <a:off x="320040" y="2724912"/>
             <a:ext cx="8503920" cy="457200"/>
           </a:xfrm>
           <a:prstGeom prst="rect">
@@ -19048,7 +19048,7 @@
         </p:nvSpPr>
         <p:spPr>
           <a:xfrm>
-            <a:off x="228600" y="3108960"/>
+            <a:off x="228600" y="3383279"/>
             <a:ext cx="8686800" cy="274320"/>
           </a:xfrm>
           <a:prstGeom prst="rect">
@@ -19087,7 +19087,7 @@
         </p:nvSpPr>
         <p:spPr>
           <a:xfrm>
-            <a:off x="228600" y="3429000"/>
+            <a:off x="228600" y="3794760"/>
             <a:ext cx="8686800" cy="640080"/>
           </a:xfrm>
           <a:prstGeom prst="rect">

</xml_diff>